<commit_message>
Update to ppt, adding poster template,
</commit_message>
<xml_diff>
--- a/final presentation.pptx
+++ b/final presentation.pptx
@@ -9702,8 +9702,8 @@
         </p:nvSpPr>
         <p:spPr>
           <a:xfrm>
-            <a:off x="7042484" y="6384394"/>
-            <a:ext cx="4919616" cy="369332"/>
+            <a:off x="6423050" y="6384394"/>
+            <a:ext cx="5687519" cy="369332"/>
           </a:xfrm>
           <a:prstGeom prst="rect">
             <a:avLst/>
@@ -9718,7 +9718,42 @@
           <a:p>
             <a:r>
               <a:rPr lang="en-US" dirty="0"/>
-              <a:t>Naomi et al. 2022. DOI: 10.2215/CJN.16541221 </a:t>
+              <a:t>Source: Naomi et al. 2022. DOI: 10.2215/CJN.16541221 </a:t>
+            </a:r>
+          </a:p>
+        </p:txBody>
+      </p:sp>
+      <p:sp>
+        <p:nvSpPr>
+          <p:cNvPr id="5" name="TextBox 4">
+            <a:extLst>
+              <a:ext uri="{FF2B5EF4-FFF2-40B4-BE49-F238E27FC236}">
+                <a16:creationId xmlns:a16="http://schemas.microsoft.com/office/drawing/2014/main" id="{871FB512-9EC0-DBCC-D366-773030C61441}"/>
+              </a:ext>
+            </a:extLst>
+          </p:cNvPr>
+          <p:cNvSpPr txBox="1"/>
+          <p:nvPr/>
+        </p:nvSpPr>
+        <p:spPr>
+          <a:xfrm>
+            <a:off x="162608" y="6476727"/>
+            <a:ext cx="5606343" cy="276999"/>
+          </a:xfrm>
+          <a:prstGeom prst="rect">
+            <a:avLst/>
+          </a:prstGeom>
+          <a:noFill/>
+        </p:spPr>
+        <p:txBody>
+          <a:bodyPr wrap="none" rtlCol="0">
+            <a:spAutoFit/>
+          </a:bodyPr>
+          <a:lstStyle/>
+          <a:p>
+            <a:r>
+              <a:rPr lang="en-US" sz="1200" dirty="0"/>
+              <a:t>Acronyms: PO = Postoperative, AKI = Acute Kidney Injury, ICU = Intensive Care Unit</a:t>
             </a:r>
           </a:p>
         </p:txBody>
@@ -15402,8 +15437,8 @@
         </p:nvSpPr>
         <p:spPr>
           <a:xfrm>
-            <a:off x="2026078" y="6533769"/>
-            <a:ext cx="8502071" cy="276999"/>
+            <a:off x="3218646" y="6550710"/>
+            <a:ext cx="8973354" cy="276999"/>
           </a:xfrm>
           <a:prstGeom prst="rect">
             <a:avLst/>
@@ -15418,7 +15453,7 @@
           <a:p>
             <a:r>
               <a:rPr lang="en-US" sz="1200" dirty="0"/>
-              <a:t>KDIGO Clinical Practice Guideline for Acute Kidney Injury. Official Journal of the International Society of Nephrology. 2012. 2(1)</a:t>
+              <a:t>Source: KDIGO Clinical Practice Guideline for Acute Kidney Injury. Official Journal of the International Society of Nephrology. 2012. 2(1)</a:t>
             </a:r>
           </a:p>
         </p:txBody>
@@ -15439,6 +15474,7 @@
         </p:nvPicPr>
         <p:blipFill>
           <a:blip r:embed="rId2"/>
+          <a:srcRect b="1246"/>
           <a:stretch>
             <a:fillRect/>
           </a:stretch>
@@ -15446,13 +15482,48 @@
         <p:spPr>
           <a:xfrm>
             <a:off x="1466438" y="806065"/>
-            <a:ext cx="9502964" cy="5639289"/>
+            <a:ext cx="9502964" cy="5569035"/>
           </a:xfrm>
           <a:prstGeom prst="rect">
             <a:avLst/>
           </a:prstGeom>
         </p:spPr>
       </p:pic>
+      <p:sp>
+        <p:nvSpPr>
+          <p:cNvPr id="5" name="TextBox 4">
+            <a:extLst>
+              <a:ext uri="{FF2B5EF4-FFF2-40B4-BE49-F238E27FC236}">
+                <a16:creationId xmlns:a16="http://schemas.microsoft.com/office/drawing/2014/main" id="{74190833-A98B-1422-60C6-22D0B52A28C9}"/>
+              </a:ext>
+            </a:extLst>
+          </p:cNvPr>
+          <p:cNvSpPr txBox="1"/>
+          <p:nvPr/>
+        </p:nvSpPr>
+        <p:spPr>
+          <a:xfrm>
+            <a:off x="294968" y="6158276"/>
+            <a:ext cx="2408903" cy="646331"/>
+          </a:xfrm>
+          <a:prstGeom prst="rect">
+            <a:avLst/>
+          </a:prstGeom>
+          <a:noFill/>
+        </p:spPr>
+        <p:txBody>
+          <a:bodyPr wrap="square" rtlCol="0">
+            <a:spAutoFit/>
+          </a:bodyPr>
+          <a:lstStyle/>
+          <a:p>
+            <a:r>
+              <a:rPr lang="en-US" sz="1200" dirty="0"/>
+              <a:t>Acronyms: KDIGO = Kidney Disease: Improving Global Outcomes</a:t>
+            </a:r>
+          </a:p>
+        </p:txBody>
+      </p:sp>
     </p:spTree>
     <p:extLst>
       <p:ext uri="{BB962C8B-B14F-4D97-AF65-F5344CB8AC3E}">
@@ -16679,7 +16750,7 @@
         </p:nvSpPr>
         <p:spPr>
           <a:xfrm>
-            <a:off x="192506" y="536471"/>
+            <a:off x="192506" y="298566"/>
             <a:ext cx="3689684" cy="1938992"/>
           </a:xfrm>
           <a:prstGeom prst="rect">
@@ -16715,8 +16786,8 @@
         </p:nvSpPr>
         <p:spPr>
           <a:xfrm>
-            <a:off x="192505" y="6308632"/>
-            <a:ext cx="3458999" cy="461665"/>
+            <a:off x="192505" y="6396335"/>
+            <a:ext cx="4067591" cy="461665"/>
           </a:xfrm>
           <a:prstGeom prst="rect">
             <a:avLst/>
@@ -16731,13 +16802,7 @@
           <a:p>
             <a:r>
               <a:rPr lang="en-US" sz="1200" dirty="0"/>
-              <a:t>Naomi et al. 2022. DOI: 10.2215/CJN.16541221</a:t>
-            </a:r>
-          </a:p>
-          <a:p>
-            <a:r>
-              <a:rPr lang="en-US" sz="1200" dirty="0"/>
-              <a:t>Wang et al. 2010. </a:t>
+              <a:t>Sources: 1) Naomi et al. 2022. DOI: 10.2215/CJN.16541221 2) Wang et al. 2010. </a:t>
             </a:r>
             <a:r>
               <a:rPr lang="en-US" sz="1200" dirty="0" err="1"/>
@@ -16811,8 +16876,8 @@
         </p:nvSpPr>
         <p:spPr>
           <a:xfrm>
-            <a:off x="94488" y="2697937"/>
-            <a:ext cx="4165608" cy="3662541"/>
+            <a:off x="94488" y="2402970"/>
+            <a:ext cx="4165608" cy="3046988"/>
           </a:xfrm>
           <a:prstGeom prst="rect">
             <a:avLst/>
@@ -16894,19 +16959,40 @@
               <a:t>Adipose: 4.4 kcal/kg/day</a:t>
             </a:r>
           </a:p>
-          <a:p>
-            <a:pPr marL="742950" lvl="1" indent="-285750">
-              <a:buFont typeface="Arial" panose="020B0604020202020204" pitchFamily="34" charset="0"/>
-              <a:buChar char="•"/>
-            </a:pPr>
-            <a:endParaRPr lang="en-US" sz="2000" dirty="0"/>
-          </a:p>
-          <a:p>
-            <a:pPr marL="742950" lvl="1" indent="-285750">
-              <a:buFont typeface="Arial" panose="020B0604020202020204" pitchFamily="34" charset="0"/>
-              <a:buChar char="•"/>
-            </a:pPr>
-            <a:endParaRPr lang="en-US" sz="2000" dirty="0"/>
+        </p:txBody>
+      </p:sp>
+      <p:sp>
+        <p:nvSpPr>
+          <p:cNvPr id="7" name="TextBox 6">
+            <a:extLst>
+              <a:ext uri="{FF2B5EF4-FFF2-40B4-BE49-F238E27FC236}">
+                <a16:creationId xmlns:a16="http://schemas.microsoft.com/office/drawing/2014/main" id="{6A89D9E2-3038-7D91-B19B-70D5F7CA3E52}"/>
+              </a:ext>
+            </a:extLst>
+          </p:cNvPr>
+          <p:cNvSpPr txBox="1"/>
+          <p:nvPr/>
+        </p:nvSpPr>
+        <p:spPr>
+          <a:xfrm>
+            <a:off x="192506" y="5917134"/>
+            <a:ext cx="2562048" cy="276999"/>
+          </a:xfrm>
+          <a:prstGeom prst="rect">
+            <a:avLst/>
+          </a:prstGeom>
+          <a:noFill/>
+        </p:spPr>
+        <p:txBody>
+          <a:bodyPr wrap="none" rtlCol="0">
+            <a:spAutoFit/>
+          </a:bodyPr>
+          <a:lstStyle/>
+          <a:p>
+            <a:r>
+              <a:rPr lang="en-US" sz="1200" dirty="0"/>
+              <a:t>Acronyms: AKI = Acute Kidney Injury</a:t>
+            </a:r>
           </a:p>
         </p:txBody>
       </p:sp>
@@ -16995,8 +17081,8 @@
         </p:nvSpPr>
         <p:spPr>
           <a:xfrm>
-            <a:off x="802105" y="1363581"/>
-            <a:ext cx="10812379" cy="5493812"/>
+            <a:off x="802104" y="1206265"/>
+            <a:ext cx="10812379" cy="5078313"/>
           </a:xfrm>
           <a:prstGeom prst="rect">
             <a:avLst/>
@@ -17078,12 +17164,40 @@
               <a:t>Postoperative hypotension is often associated with increased incidence of PO-AKI. Some studies suggest maintaining a postoperative MAP of &gt;75 – 90 mmHg.</a:t>
             </a:r>
           </a:p>
-          <a:p>
-            <a:pPr marL="285750" indent="-285750">
-              <a:buFont typeface="Arial" panose="020B0604020202020204" pitchFamily="34" charset="0"/>
-              <a:buChar char="•"/>
-            </a:pPr>
-            <a:endParaRPr lang="en-US" sz="2700" dirty="0"/>
+        </p:txBody>
+      </p:sp>
+      <p:sp>
+        <p:nvSpPr>
+          <p:cNvPr id="4" name="TextBox 3">
+            <a:extLst>
+              <a:ext uri="{FF2B5EF4-FFF2-40B4-BE49-F238E27FC236}">
+                <a16:creationId xmlns:a16="http://schemas.microsoft.com/office/drawing/2014/main" id="{A8354170-51A8-C799-1FFA-00FD3C239C03}"/>
+              </a:ext>
+            </a:extLst>
+          </p:cNvPr>
+          <p:cNvSpPr txBox="1"/>
+          <p:nvPr/>
+        </p:nvSpPr>
+        <p:spPr>
+          <a:xfrm>
+            <a:off x="162608" y="6476727"/>
+            <a:ext cx="5900783" cy="276999"/>
+          </a:xfrm>
+          <a:prstGeom prst="rect">
+            <a:avLst/>
+          </a:prstGeom>
+          <a:noFill/>
+        </p:spPr>
+        <p:txBody>
+          <a:bodyPr wrap="none" rtlCol="0">
+            <a:spAutoFit/>
+          </a:bodyPr>
+          <a:lstStyle/>
+          <a:p>
+            <a:r>
+              <a:rPr lang="en-US" sz="1200" dirty="0"/>
+              <a:t>Acronyms: PO = Postoperative, AKI = Acute Kidney Injury, MAP = Mean Arterial Pressure</a:t>
+            </a:r>
           </a:p>
         </p:txBody>
       </p:sp>
@@ -17747,6 +17861,41 @@
               <a:t>Credentialed access through PhysioNet with local loading into PostgreSQL, or cloud querying through BigQuery.</a:t>
             </a:r>
             <a:endParaRPr lang="en-US" sz="1400" dirty="0"/>
+          </a:p>
+        </p:txBody>
+      </p:sp>
+      <p:sp>
+        <p:nvSpPr>
+          <p:cNvPr id="19" name="TextBox 18">
+            <a:extLst>
+              <a:ext uri="{FF2B5EF4-FFF2-40B4-BE49-F238E27FC236}">
+                <a16:creationId xmlns:a16="http://schemas.microsoft.com/office/drawing/2014/main" id="{DAF42FC7-8B4D-93CE-46C1-20495CBC94A5}"/>
+              </a:ext>
+            </a:extLst>
+          </p:cNvPr>
+          <p:cNvSpPr txBox="1"/>
+          <p:nvPr/>
+        </p:nvSpPr>
+        <p:spPr>
+          <a:xfrm>
+            <a:off x="93782" y="6381172"/>
+            <a:ext cx="8076763" cy="276999"/>
+          </a:xfrm>
+          <a:prstGeom prst="rect">
+            <a:avLst/>
+          </a:prstGeom>
+          <a:noFill/>
+        </p:spPr>
+        <p:txBody>
+          <a:bodyPr wrap="none" rtlCol="0">
+            <a:spAutoFit/>
+          </a:bodyPr>
+          <a:lstStyle/>
+          <a:p>
+            <a:r>
+              <a:rPr lang="en-US" sz="1200" dirty="0"/>
+              <a:t>Acronyms: MIMIC = Medical Information Mart for Intensive Care, EHR = Electron Health Record, ICU = Intensive Care Unit</a:t>
+            </a:r>
           </a:p>
         </p:txBody>
       </p:sp>

</xml_diff>